<commit_message>
2026-10-16 updates 2 Enhanced Dashboard
</commit_message>
<xml_diff>
--- a/Personal Finance Management System.pptx
+++ b/Personal Finance Management System.pptx
@@ -7700,10 +7700,10 @@
       </p:sp>
       <p:pic>
         <p:nvPicPr>
-          <p:cNvPr id="14" name="Picture 13">
+          <p:cNvPr id="16" name="Picture 15">
             <a:extLst>
               <a:ext uri="{FF2B5EF4-FFF2-40B4-BE49-F238E27FC236}">
-                <a16:creationId xmlns:a16="http://schemas.microsoft.com/office/drawing/2014/main" id="{6ADEB588-0DE5-EAFB-7695-430422418F34}"/>
+                <a16:creationId xmlns:a16="http://schemas.microsoft.com/office/drawing/2014/main" id="{7955133F-FEF2-AFA4-619C-9482B0372552}"/>
               </a:ext>
             </a:extLst>
           </p:cNvPr>
@@ -7720,8 +7720,8 @@
         </p:blipFill>
         <p:spPr>
           <a:xfrm>
-            <a:off x="3563284" y="2561150"/>
-            <a:ext cx="4608232" cy="2590866"/>
+            <a:off x="3385343" y="2299245"/>
+            <a:ext cx="5421313" cy="3048000"/>
           </a:xfrm>
           <a:prstGeom prst="rect">
             <a:avLst/>

</xml_diff>